<commit_message>
Telão: 16 telas com o slide único de Cuidar da saúde
Co-Authored-By: Claude Sonnet 5.5 <noreply@anthropic.com>
Claude-Session: https://claude.ai/code/session_01W2vvvRN4gDADzPtasSS9Lx
</commit_message>
<xml_diff>
--- a/telao/telao_connect_valley.pptx
+++ b/telao/telao_connect_valley.pptx
@@ -21,7 +21,6 @@
     <p:sldId id="269" r:id="rId20"/>
     <p:sldId id="270" r:id="rId21"/>
     <p:sldId id="271" r:id="rId22"/>
-    <p:sldId id="272" r:id="rId23"/>
   </p:sldIdLst>
   <p:sldSz cx="12192000" cy="6858000" type="screen4x3"/>
   <p:notesSz cx="6858000" cy="9144000"/>
@@ -3849,28 +3848,28 @@
         </p:nvSpPr>
         <p:spPr>
           <a:xfrm>
-            <a:off x="698500" y="1235710"/>
-            <a:ext cx="2404864" cy="685800"/>
-          </a:xfrm>
-          <a:prstGeom prst="rect">
-            <a:avLst/>
-          </a:prstGeom>
-          <a:noFill/>
-        </p:spPr>
-        <p:txBody>
-          <a:bodyPr wrap="none" lIns="0" rIns="0" tIns="0" bIns="0" anchor="t">
-            <a:spAutoFit/>
-          </a:bodyPr>
-          <a:lstStyle/>
-          <a:p>
-            <a:r>
-              <a:rPr sz="5350">
+            <a:off x="698500" y="1663445"/>
+            <a:ext cx="4297362" cy="533400"/>
+          </a:xfrm>
+          <a:prstGeom prst="rect">
+            <a:avLst/>
+          </a:prstGeom>
+          <a:noFill/>
+        </p:spPr>
+        <p:txBody>
+          <a:bodyPr wrap="none" lIns="0" rIns="0" tIns="0" bIns="0" anchor="t">
+            <a:spAutoFit/>
+          </a:bodyPr>
+          <a:lstStyle/>
+          <a:p>
+            <a:r>
+              <a:rPr sz="4200">
                 <a:solidFill>
                   <a:srgbClr val="4B0F2F"/>
                 </a:solidFill>
                 <a:latin typeface="Intro Bold"/>
               </a:rPr>
-              <a:t>Cuidar</a:t>
+              <a:t>Cuidar da saúde</a:t>
             </a:r>
           </a:p>
         </p:txBody>
@@ -3883,28 +3882,28 @@
         </p:nvSpPr>
         <p:spPr>
           <a:xfrm>
-            <a:off x="698500" y="2003806"/>
-            <a:ext cx="977304" cy="685800"/>
-          </a:xfrm>
-          <a:prstGeom prst="rect">
-            <a:avLst/>
-          </a:prstGeom>
-          <a:noFill/>
-        </p:spPr>
-        <p:txBody>
-          <a:bodyPr wrap="none" lIns="0" rIns="0" tIns="0" bIns="0" anchor="t">
-            <a:spAutoFit/>
-          </a:bodyPr>
-          <a:lstStyle/>
-          <a:p>
-            <a:r>
-              <a:rPr sz="5350">
+            <a:off x="698500" y="2260854"/>
+            <a:ext cx="3791942" cy="533400"/>
+          </a:xfrm>
+          <a:prstGeom prst="rect">
+            <a:avLst/>
+          </a:prstGeom>
+          <a:noFill/>
+        </p:spPr>
+        <p:txBody>
+          <a:bodyPr wrap="none" lIns="0" rIns="0" tIns="0" bIns="0" anchor="t">
+            <a:spAutoFit/>
+          </a:bodyPr>
+          <a:lstStyle/>
+          <a:p>
+            <a:r>
+              <a:rPr sz="4200">
                 <a:solidFill>
                   <a:srgbClr val="4B0F2F"/>
                 </a:solidFill>
                 <a:latin typeface="Intro Bold"/>
               </a:rPr>
-              <a:t>da</a:t>
+              <a:t>pode ser caro.</a:t>
             </a:r>
           </a:p>
         </p:txBody>
@@ -3917,28 +3916,28 @@
         </p:nvSpPr>
         <p:spPr>
           <a:xfrm>
-            <a:off x="698500" y="2771902"/>
-            <a:ext cx="2105818" cy="685800"/>
-          </a:xfrm>
-          <a:prstGeom prst="rect">
-            <a:avLst/>
-          </a:prstGeom>
-          <a:noFill/>
-        </p:spPr>
-        <p:txBody>
-          <a:bodyPr wrap="none" lIns="0" rIns="0" tIns="0" bIns="0" anchor="t">
-            <a:spAutoFit/>
-          </a:bodyPr>
-          <a:lstStyle/>
-          <a:p>
-            <a:r>
-              <a:rPr sz="5350">
+            <a:off x="698500" y="3041904"/>
+            <a:ext cx="3366690" cy="533400"/>
+          </a:xfrm>
+          <a:prstGeom prst="rect">
+            <a:avLst/>
+          </a:prstGeom>
+          <a:noFill/>
+        </p:spPr>
+        <p:txBody>
+          <a:bodyPr wrap="none" lIns="0" rIns="0" tIns="0" bIns="0" anchor="t">
+            <a:spAutoFit/>
+          </a:bodyPr>
+          <a:lstStyle/>
+          <a:p>
+            <a:r>
+              <a:rPr sz="4200">
                 <a:solidFill>
                   <a:srgbClr val="4B0F2F"/>
                 </a:solidFill>
                 <a:latin typeface="Intro Bold"/>
               </a:rPr>
-              <a:t>saúde</a:t>
+              <a:t>Não cuidar é</a:t>
             </a:r>
           </a:p>
         </p:txBody>
@@ -3951,96 +3950,62 @@
         </p:nvSpPr>
         <p:spPr>
           <a:xfrm>
-            <a:off x="698500" y="3539998"/>
-            <a:ext cx="1775618" cy="685800"/>
-          </a:xfrm>
-          <a:prstGeom prst="rect">
-            <a:avLst/>
-          </a:prstGeom>
-          <a:noFill/>
-        </p:spPr>
-        <p:txBody>
-          <a:bodyPr wrap="none" lIns="0" rIns="0" tIns="0" bIns="0" anchor="t">
-            <a:spAutoFit/>
-          </a:bodyPr>
-          <a:lstStyle/>
-          <a:p>
-            <a:r>
-              <a:rPr sz="5350">
+            <a:off x="698500" y="3664204"/>
+            <a:ext cx="5375076" cy="1117600"/>
+          </a:xfrm>
+          <a:prstGeom prst="rect">
+            <a:avLst/>
+          </a:prstGeom>
+          <a:noFill/>
+        </p:spPr>
+        <p:txBody>
+          <a:bodyPr wrap="none" lIns="0" rIns="0" tIns="0" bIns="0" anchor="t">
+            <a:spAutoFit/>
+          </a:bodyPr>
+          <a:lstStyle/>
+          <a:p>
+            <a:r>
+              <a:rPr sz="8800">
+                <a:solidFill>
+                  <a:srgbClr val="FF6F68"/>
+                </a:solidFill>
+                <a:latin typeface="Intro Bold"/>
+              </a:rPr>
+              <a:t>mais caro</a:t>
+            </a:r>
+          </a:p>
+        </p:txBody>
+      </p:sp>
+      <p:sp>
+        <p:nvSpPr>
+          <p:cNvPr id="7" name="TextBox 6"/>
+          <p:cNvSpPr txBox="1"/>
+          <p:nvPr/>
+        </p:nvSpPr>
+        <p:spPr>
+          <a:xfrm>
+            <a:off x="698500" y="4769104"/>
+            <a:ext cx="1724521" cy="533400"/>
+          </a:xfrm>
+          <a:prstGeom prst="rect">
+            <a:avLst/>
+          </a:prstGeom>
+          <a:noFill/>
+        </p:spPr>
+        <p:txBody>
+          <a:bodyPr wrap="none" lIns="0" rIns="0" tIns="0" bIns="0" anchor="t">
+            <a:spAutoFit/>
+          </a:bodyPr>
+          <a:lstStyle/>
+          <a:p>
+            <a:r>
+              <a:rPr sz="4200">
                 <a:solidFill>
                   <a:srgbClr val="4B0F2F"/>
                 </a:solidFill>
                 <a:latin typeface="Intro Bold"/>
               </a:rPr>
-              <a:t>pode</a:t>
-            </a:r>
-          </a:p>
-        </p:txBody>
-      </p:sp>
-      <p:sp>
-        <p:nvSpPr>
-          <p:cNvPr id="7" name="TextBox 6"/>
-          <p:cNvSpPr txBox="1"/>
-          <p:nvPr/>
-        </p:nvSpPr>
-        <p:spPr>
-          <a:xfrm>
-            <a:off x="698500" y="4308094"/>
-            <a:ext cx="1225946" cy="685800"/>
-          </a:xfrm>
-          <a:prstGeom prst="rect">
-            <a:avLst/>
-          </a:prstGeom>
-          <a:noFill/>
-        </p:spPr>
-        <p:txBody>
-          <a:bodyPr wrap="none" lIns="0" rIns="0" tIns="0" bIns="0" anchor="t">
-            <a:spAutoFit/>
-          </a:bodyPr>
-          <a:lstStyle/>
-          <a:p>
-            <a:r>
-              <a:rPr sz="5350">
-                <a:solidFill>
-                  <a:srgbClr val="4B0F2F"/>
-                </a:solidFill>
-                <a:latin typeface="Intro Bold"/>
-              </a:rPr>
-              <a:t>ser</a:t>
-            </a:r>
-          </a:p>
-        </p:txBody>
-      </p:sp>
-      <p:sp>
-        <p:nvSpPr>
-          <p:cNvPr id="8" name="TextBox 7"/>
-          <p:cNvSpPr txBox="1"/>
-          <p:nvPr/>
-        </p:nvSpPr>
-        <p:spPr>
-          <a:xfrm>
-            <a:off x="698500" y="5076190"/>
-            <a:ext cx="1842293" cy="685800"/>
-          </a:xfrm>
-          <a:prstGeom prst="rect">
-            <a:avLst/>
-          </a:prstGeom>
-          <a:noFill/>
-        </p:spPr>
-        <p:txBody>
-          <a:bodyPr wrap="none" lIns="0" rIns="0" tIns="0" bIns="0" anchor="t">
-            <a:spAutoFit/>
-          </a:bodyPr>
-          <a:lstStyle/>
-          <a:p>
-            <a:r>
-              <a:rPr sz="5350">
-                <a:solidFill>
-                  <a:srgbClr val="4B0F2F"/>
-                </a:solidFill>
-                <a:latin typeface="Intro Bold"/>
-              </a:rPr>
-              <a:t>caro.</a:t>
+              <a:t>ainda.</a:t>
             </a:r>
           </a:p>
         </p:txBody>
@@ -4050,7 +4015,7 @@
   <p:clrMapOvr>
     <a:masterClrMapping/>
   </p:clrMapOvr>
-  <p:transition spd="med" advTm="6000">
+  <p:transition spd="med" advTm="8000">
     <p:fade/>
   </p:transition>
 </p:sld>
@@ -4068,7 +4033,7 @@
       <p:grpSpPr/>
       <p:pic>
         <p:nvPicPr>
-          <p:cNvPr id="2" name="Picture 1" descr="tela_12.png"/>
+          <p:cNvPr id="2" name="Picture 1" descr="tela_13.png"/>
           <p:cNvPicPr>
             <a:picLocks noChangeAspect="1"/>
           </p:cNvPicPr>
@@ -4098,28 +4063,28 @@
         </p:nvSpPr>
         <p:spPr>
           <a:xfrm>
-            <a:off x="698500" y="1334135"/>
-            <a:ext cx="1621532" cy="762000"/>
-          </a:xfrm>
-          <a:prstGeom prst="rect">
-            <a:avLst/>
-          </a:prstGeom>
-          <a:noFill/>
-        </p:spPr>
-        <p:txBody>
-          <a:bodyPr wrap="none" lIns="0" rIns="0" tIns="0" bIns="0" anchor="t">
-            <a:spAutoFit/>
-          </a:bodyPr>
-          <a:lstStyle/>
-          <a:p>
-            <a:r>
-              <a:rPr sz="6000">
+            <a:off x="698500" y="1223518"/>
+            <a:ext cx="4305696" cy="552450"/>
+          </a:xfrm>
+          <a:prstGeom prst="rect">
+            <a:avLst/>
+          </a:prstGeom>
+          <a:noFill/>
+        </p:spPr>
+        <p:txBody>
+          <a:bodyPr wrap="none" lIns="0" rIns="0" tIns="0" bIns="0" anchor="t">
+            <a:spAutoFit/>
+          </a:bodyPr>
+          <a:lstStyle/>
+          <a:p>
+            <a:r>
+              <a:rPr sz="4300">
                 <a:solidFill>
                   <a:srgbClr val="4B0F2F"/>
                 </a:solidFill>
                 <a:latin typeface="Intro Bold"/>
               </a:rPr>
-              <a:t>Não</a:t>
+              <a:t>Saúde na palma</a:t>
             </a:r>
           </a:p>
         </p:txBody>
@@ -4132,28 +4097,28 @@
         </p:nvSpPr>
         <p:spPr>
           <a:xfrm>
-            <a:off x="698500" y="2187575"/>
-            <a:ext cx="2523827" cy="762000"/>
-          </a:xfrm>
-          <a:prstGeom prst="rect">
-            <a:avLst/>
-          </a:prstGeom>
-          <a:noFill/>
-        </p:spPr>
-        <p:txBody>
-          <a:bodyPr wrap="none" lIns="0" rIns="0" tIns="0" bIns="0" anchor="t">
-            <a:spAutoFit/>
-          </a:bodyPr>
-          <a:lstStyle/>
-          <a:p>
-            <a:r>
-              <a:rPr sz="6000">
+            <a:off x="698500" y="1835150"/>
+            <a:ext cx="2221408" cy="552450"/>
+          </a:xfrm>
+          <a:prstGeom prst="rect">
+            <a:avLst/>
+          </a:prstGeom>
+          <a:noFill/>
+        </p:spPr>
+        <p:txBody>
+          <a:bodyPr wrap="none" lIns="0" rIns="0" tIns="0" bIns="0" anchor="t">
+            <a:spAutoFit/>
+          </a:bodyPr>
+          <a:lstStyle/>
+          <a:p>
+            <a:r>
+              <a:rPr sz="4300">
                 <a:solidFill>
                   <a:srgbClr val="4B0F2F"/>
                 </a:solidFill>
                 <a:latin typeface="Intro Bold"/>
               </a:rPr>
-              <a:t>cuidar</a:t>
+              <a:t>da mão.</a:t>
             </a:r>
           </a:p>
         </p:txBody>
@@ -4166,96 +4131,164 @@
         </p:nvSpPr>
         <p:spPr>
           <a:xfrm>
-            <a:off x="698500" y="3041015"/>
-            <a:ext cx="610393" cy="762000"/>
-          </a:xfrm>
-          <a:prstGeom prst="rect">
-            <a:avLst/>
-          </a:prstGeom>
-          <a:noFill/>
-        </p:spPr>
-        <p:txBody>
-          <a:bodyPr wrap="none" lIns="0" rIns="0" tIns="0" bIns="0" anchor="t">
-            <a:spAutoFit/>
-          </a:bodyPr>
-          <a:lstStyle/>
-          <a:p>
-            <a:r>
-              <a:rPr sz="6000">
+            <a:off x="698500" y="2446782"/>
+            <a:ext cx="5319414" cy="552450"/>
+          </a:xfrm>
+          <a:prstGeom prst="rect">
+            <a:avLst/>
+          </a:prstGeom>
+          <a:noFill/>
+        </p:spPr>
+        <p:txBody>
+          <a:bodyPr wrap="none" lIns="0" rIns="0" tIns="0" bIns="0" anchor="t">
+            <a:spAutoFit/>
+          </a:bodyPr>
+          <a:lstStyle/>
+          <a:p>
+            <a:r>
+              <a:rPr sz="4300">
+                <a:solidFill>
+                  <a:srgbClr val="FF6F68"/>
+                </a:solidFill>
+                <a:latin typeface="Intro Bold"/>
+              </a:rPr>
+              <a:t>Sem deslocamento.</a:t>
+            </a:r>
+          </a:p>
+        </p:txBody>
+      </p:sp>
+      <p:sp>
+        <p:nvSpPr>
+          <p:cNvPr id="6" name="TextBox 5"/>
+          <p:cNvSpPr txBox="1"/>
+          <p:nvPr/>
+        </p:nvSpPr>
+        <p:spPr>
+          <a:xfrm>
+            <a:off x="1244600" y="3288156"/>
+            <a:ext cx="1772542" cy="203200"/>
+          </a:xfrm>
+          <a:prstGeom prst="rect">
+            <a:avLst/>
+          </a:prstGeom>
+          <a:noFill/>
+        </p:spPr>
+        <p:txBody>
+          <a:bodyPr wrap="none" lIns="0" rIns="0" tIns="0" bIns="0" anchor="t">
+            <a:spAutoFit/>
+          </a:bodyPr>
+          <a:lstStyle/>
+          <a:p>
+            <a:r>
+              <a:rPr sz="1550">
                 <a:solidFill>
                   <a:srgbClr val="4B0F2F"/>
                 </a:solidFill>
                 <a:latin typeface="Intro Bold"/>
               </a:rPr>
-              <a:t>é</a:t>
-            </a:r>
-          </a:p>
-        </p:txBody>
-      </p:sp>
-      <p:sp>
-        <p:nvSpPr>
-          <p:cNvPr id="6" name="TextBox 5"/>
-          <p:cNvSpPr txBox="1"/>
-          <p:nvPr/>
-        </p:nvSpPr>
-        <p:spPr>
-          <a:xfrm>
-            <a:off x="698500" y="3828415"/>
-            <a:ext cx="5375076" cy="1117600"/>
-          </a:xfrm>
-          <a:prstGeom prst="rect">
-            <a:avLst/>
-          </a:prstGeom>
-          <a:noFill/>
-        </p:spPr>
-        <p:txBody>
-          <a:bodyPr wrap="none" lIns="0" rIns="0" tIns="0" bIns="0" anchor="t">
-            <a:spAutoFit/>
-          </a:bodyPr>
-          <a:lstStyle/>
-          <a:p>
-            <a:r>
-              <a:rPr sz="8800">
-                <a:solidFill>
-                  <a:srgbClr val="FF6F68"/>
+              <a:t>Clínico geral 24h</a:t>
+            </a:r>
+          </a:p>
+        </p:txBody>
+      </p:sp>
+      <p:sp>
+        <p:nvSpPr>
+          <p:cNvPr id="7" name="TextBox 6"/>
+          <p:cNvSpPr txBox="1"/>
+          <p:nvPr/>
+        </p:nvSpPr>
+        <p:spPr>
+          <a:xfrm>
+            <a:off x="1244600" y="3948556"/>
+            <a:ext cx="2562026" cy="203200"/>
+          </a:xfrm>
+          <a:prstGeom prst="rect">
+            <a:avLst/>
+          </a:prstGeom>
+          <a:noFill/>
+        </p:spPr>
+        <p:txBody>
+          <a:bodyPr wrap="none" lIns="0" rIns="0" tIns="0" bIns="0" anchor="t">
+            <a:spAutoFit/>
+          </a:bodyPr>
+          <a:lstStyle/>
+          <a:p>
+            <a:r>
+              <a:rPr sz="1550">
+                <a:solidFill>
+                  <a:srgbClr val="4B0F2F"/>
                 </a:solidFill>
                 <a:latin typeface="Intro Bold"/>
               </a:rPr>
-              <a:t>mais caro</a:t>
-            </a:r>
-          </a:p>
-        </p:txBody>
-      </p:sp>
-      <p:sp>
-        <p:nvSpPr>
-          <p:cNvPr id="7" name="TextBox 6"/>
-          <p:cNvSpPr txBox="1"/>
-          <p:nvPr/>
-        </p:nvSpPr>
-        <p:spPr>
-          <a:xfrm>
-            <a:off x="698500" y="4933315"/>
-            <a:ext cx="2382142" cy="762000"/>
-          </a:xfrm>
-          <a:prstGeom prst="rect">
-            <a:avLst/>
-          </a:prstGeom>
-          <a:noFill/>
-        </p:spPr>
-        <p:txBody>
-          <a:bodyPr wrap="none" lIns="0" rIns="0" tIns="0" bIns="0" anchor="t">
-            <a:spAutoFit/>
-          </a:bodyPr>
-          <a:lstStyle/>
-          <a:p>
-            <a:r>
-              <a:rPr sz="6000">
+              <a:t>Mais de 12 especialidades</a:t>
+            </a:r>
+          </a:p>
+        </p:txBody>
+      </p:sp>
+      <p:sp>
+        <p:nvSpPr>
+          <p:cNvPr id="8" name="TextBox 7"/>
+          <p:cNvSpPr txBox="1"/>
+          <p:nvPr/>
+        </p:nvSpPr>
+        <p:spPr>
+          <a:xfrm>
+            <a:off x="1244600" y="4596257"/>
+            <a:ext cx="2163365" cy="203200"/>
+          </a:xfrm>
+          <a:prstGeom prst="rect">
+            <a:avLst/>
+          </a:prstGeom>
+          <a:noFill/>
+        </p:spPr>
+        <p:txBody>
+          <a:bodyPr wrap="none" lIns="0" rIns="0" tIns="0" bIns="0" anchor="t">
+            <a:spAutoFit/>
+          </a:bodyPr>
+          <a:lstStyle/>
+          <a:p>
+            <a:r>
+              <a:rPr sz="1550">
                 <a:solidFill>
                   <a:srgbClr val="4B0F2F"/>
                 </a:solidFill>
                 <a:latin typeface="Intro Bold"/>
               </a:rPr>
-              <a:t>ainda.</a:t>
+              <a:t>Psicologia e nutrição</a:t>
+            </a:r>
+          </a:p>
+        </p:txBody>
+      </p:sp>
+      <p:sp>
+        <p:nvSpPr>
+          <p:cNvPr id="9" name="TextBox 8"/>
+          <p:cNvSpPr txBox="1"/>
+          <p:nvPr/>
+        </p:nvSpPr>
+        <p:spPr>
+          <a:xfrm>
+            <a:off x="1244600" y="5253482"/>
+            <a:ext cx="3952875" cy="203200"/>
+          </a:xfrm>
+          <a:prstGeom prst="rect">
+            <a:avLst/>
+          </a:prstGeom>
+          <a:noFill/>
+        </p:spPr>
+        <p:txBody>
+          <a:bodyPr wrap="none" lIns="0" rIns="0" tIns="0" bIns="0" anchor="t">
+            <a:spAutoFit/>
+          </a:bodyPr>
+          <a:lstStyle/>
+          <a:p>
+            <a:r>
+              <a:rPr sz="1550">
+                <a:solidFill>
+                  <a:srgbClr val="4B0F2F"/>
+                </a:solidFill>
+                <a:latin typeface="Intro Bold"/>
+              </a:rPr>
+              <a:t>Clubes de benefícios nacional e regional</a:t>
             </a:r>
           </a:p>
         </p:txBody>
@@ -4265,7 +4298,7 @@
   <p:clrMapOvr>
     <a:masterClrMapping/>
   </p:clrMapOvr>
-  <p:transition spd="med" advTm="7000">
+  <p:transition spd="med" advTm="9000">
     <p:fade/>
   </p:transition>
 </p:sld>
@@ -4313,28 +4346,28 @@
         </p:nvSpPr>
         <p:spPr>
           <a:xfrm>
-            <a:off x="698500" y="1223518"/>
-            <a:ext cx="4305696" cy="552450"/>
-          </a:xfrm>
-          <a:prstGeom prst="rect">
-            <a:avLst/>
-          </a:prstGeom>
-          <a:noFill/>
-        </p:spPr>
-        <p:txBody>
-          <a:bodyPr wrap="none" lIns="0" rIns="0" tIns="0" bIns="0" anchor="t">
-            <a:spAutoFit/>
-          </a:bodyPr>
-          <a:lstStyle/>
-          <a:p>
-            <a:r>
-              <a:rPr sz="4300">
+            <a:off x="1687859" y="1543050"/>
+            <a:ext cx="9006780" cy="533400"/>
+          </a:xfrm>
+          <a:prstGeom prst="rect">
+            <a:avLst/>
+          </a:prstGeom>
+          <a:noFill/>
+        </p:spPr>
+        <p:txBody>
+          <a:bodyPr wrap="none" lIns="0" rIns="0" tIns="0" bIns="0" anchor="t">
+            <a:spAutoFit/>
+          </a:bodyPr>
+          <a:lstStyle/>
+          <a:p>
+            <a:r>
+              <a:rPr sz="4200">
                 <a:solidFill>
                   <a:srgbClr val="4B0F2F"/>
                 </a:solidFill>
                 <a:latin typeface="Intro Bold"/>
               </a:rPr>
-              <a:t>Saúde na palma</a:t>
+              <a:t>Quem já escolheu cuidar da equipe</a:t>
             </a:r>
           </a:p>
         </p:txBody>
@@ -4347,198 +4380,232 @@
         </p:nvSpPr>
         <p:spPr>
           <a:xfrm>
-            <a:off x="698500" y="1835150"/>
-            <a:ext cx="2221408" cy="552450"/>
-          </a:xfrm>
-          <a:prstGeom prst="rect">
-            <a:avLst/>
-          </a:prstGeom>
-          <a:noFill/>
-        </p:spPr>
-        <p:txBody>
-          <a:bodyPr wrap="none" lIns="0" rIns="0" tIns="0" bIns="0" anchor="t">
-            <a:spAutoFit/>
-          </a:bodyPr>
-          <a:lstStyle/>
-          <a:p>
-            <a:r>
-              <a:rPr sz="4300">
+            <a:off x="1849288" y="2933700"/>
+            <a:ext cx="1825922" cy="958850"/>
+          </a:xfrm>
+          <a:prstGeom prst="rect">
+            <a:avLst/>
+          </a:prstGeom>
+          <a:noFill/>
+        </p:spPr>
+        <p:txBody>
+          <a:bodyPr wrap="none" lIns="0" rIns="0" tIns="0" bIns="0" anchor="t">
+            <a:spAutoFit/>
+          </a:bodyPr>
+          <a:lstStyle/>
+          <a:p>
+            <a:r>
+              <a:rPr sz="7500">
+                <a:solidFill>
+                  <a:srgbClr val="FF6F68"/>
+                </a:solidFill>
+                <a:latin typeface="Intro Bold"/>
+              </a:rPr>
+              <a:t>+50</a:t>
+            </a:r>
+          </a:p>
+        </p:txBody>
+      </p:sp>
+      <p:sp>
+        <p:nvSpPr>
+          <p:cNvPr id="5" name="TextBox 4"/>
+          <p:cNvSpPr txBox="1"/>
+          <p:nvPr/>
+        </p:nvSpPr>
+        <p:spPr>
+          <a:xfrm>
+            <a:off x="1617960" y="4133850"/>
+            <a:ext cx="2288579" cy="247650"/>
+          </a:xfrm>
+          <a:prstGeom prst="rect">
+            <a:avLst/>
+          </a:prstGeom>
+          <a:noFill/>
+        </p:spPr>
+        <p:txBody>
+          <a:bodyPr wrap="none" lIns="0" rIns="0" tIns="0" bIns="0" anchor="t">
+            <a:spAutoFit/>
+          </a:bodyPr>
+          <a:lstStyle/>
+          <a:p>
+            <a:r>
+              <a:rPr sz="1900">
                 <a:solidFill>
                   <a:srgbClr val="4B0F2F"/>
                 </a:solidFill>
                 <a:latin typeface="Intro Bold"/>
               </a:rPr>
-              <a:t>da mão.</a:t>
-            </a:r>
-          </a:p>
-        </p:txBody>
-      </p:sp>
-      <p:sp>
-        <p:nvSpPr>
-          <p:cNvPr id="5" name="TextBox 4"/>
-          <p:cNvSpPr txBox="1"/>
-          <p:nvPr/>
-        </p:nvSpPr>
-        <p:spPr>
-          <a:xfrm>
-            <a:off x="698500" y="2446782"/>
-            <a:ext cx="5319414" cy="552450"/>
-          </a:xfrm>
-          <a:prstGeom prst="rect">
-            <a:avLst/>
-          </a:prstGeom>
-          <a:noFill/>
-        </p:spPr>
-        <p:txBody>
-          <a:bodyPr wrap="none" lIns="0" rIns="0" tIns="0" bIns="0" anchor="t">
-            <a:spAutoFit/>
-          </a:bodyPr>
-          <a:lstStyle/>
-          <a:p>
-            <a:r>
-              <a:rPr sz="4300">
+              <a:t>empresas clientes</a:t>
+            </a:r>
+          </a:p>
+        </p:txBody>
+      </p:sp>
+      <p:sp>
+        <p:nvSpPr>
+          <p:cNvPr id="6" name="TextBox 5"/>
+          <p:cNvSpPr txBox="1"/>
+          <p:nvPr/>
+        </p:nvSpPr>
+        <p:spPr>
+          <a:xfrm>
+            <a:off x="4832796" y="3067050"/>
+            <a:ext cx="2716907" cy="781050"/>
+          </a:xfrm>
+          <a:prstGeom prst="rect">
+            <a:avLst/>
+          </a:prstGeom>
+          <a:noFill/>
+        </p:spPr>
+        <p:txBody>
+          <a:bodyPr wrap="none" lIns="0" rIns="0" tIns="0" bIns="0" anchor="t">
+            <a:spAutoFit/>
+          </a:bodyPr>
+          <a:lstStyle/>
+          <a:p>
+            <a:r>
+              <a:rPr sz="6100">
                 <a:solidFill>
                   <a:srgbClr val="FF6F68"/>
                 </a:solidFill>
                 <a:latin typeface="Intro Bold"/>
               </a:rPr>
-              <a:t>Sem deslocamento.</a:t>
-            </a:r>
-          </a:p>
-        </p:txBody>
-      </p:sp>
-      <p:sp>
-        <p:nvSpPr>
-          <p:cNvPr id="6" name="TextBox 5"/>
-          <p:cNvSpPr txBox="1"/>
-          <p:nvPr/>
-        </p:nvSpPr>
-        <p:spPr>
-          <a:xfrm>
-            <a:off x="1244600" y="3288156"/>
-            <a:ext cx="1772542" cy="203200"/>
-          </a:xfrm>
-          <a:prstGeom prst="rect">
-            <a:avLst/>
-          </a:prstGeom>
-          <a:noFill/>
-        </p:spPr>
-        <p:txBody>
-          <a:bodyPr wrap="none" lIns="0" rIns="0" tIns="0" bIns="0" anchor="t">
-            <a:spAutoFit/>
-          </a:bodyPr>
-          <a:lstStyle/>
-          <a:p>
-            <a:r>
-              <a:rPr sz="1550">
+              <a:t>+2.000</a:t>
+            </a:r>
+          </a:p>
+        </p:txBody>
+      </p:sp>
+      <p:sp>
+        <p:nvSpPr>
+          <p:cNvPr id="7" name="TextBox 6"/>
+          <p:cNvSpPr txBox="1"/>
+          <p:nvPr/>
+        </p:nvSpPr>
+        <p:spPr>
+          <a:xfrm>
+            <a:off x="4876651" y="4133850"/>
+            <a:ext cx="2629197" cy="247650"/>
+          </a:xfrm>
+          <a:prstGeom prst="rect">
+            <a:avLst/>
+          </a:prstGeom>
+          <a:noFill/>
+        </p:spPr>
+        <p:txBody>
+          <a:bodyPr wrap="none" lIns="0" rIns="0" tIns="0" bIns="0" anchor="t">
+            <a:spAutoFit/>
+          </a:bodyPr>
+          <a:lstStyle/>
+          <a:p>
+            <a:r>
+              <a:rPr sz="1900">
                 <a:solidFill>
                   <a:srgbClr val="4B0F2F"/>
                 </a:solidFill>
                 <a:latin typeface="Intro Bold"/>
               </a:rPr>
-              <a:t>Clínico geral 24h</a:t>
-            </a:r>
-          </a:p>
-        </p:txBody>
-      </p:sp>
-      <p:sp>
-        <p:nvSpPr>
-          <p:cNvPr id="7" name="TextBox 6"/>
-          <p:cNvSpPr txBox="1"/>
-          <p:nvPr/>
-        </p:nvSpPr>
-        <p:spPr>
-          <a:xfrm>
-            <a:off x="1244600" y="3948556"/>
-            <a:ext cx="2562026" cy="203200"/>
-          </a:xfrm>
-          <a:prstGeom prst="rect">
-            <a:avLst/>
-          </a:prstGeom>
-          <a:noFill/>
-        </p:spPr>
-        <p:txBody>
-          <a:bodyPr wrap="none" lIns="0" rIns="0" tIns="0" bIns="0" anchor="t">
-            <a:spAutoFit/>
-          </a:bodyPr>
-          <a:lstStyle/>
-          <a:p>
-            <a:r>
-              <a:rPr sz="1550">
+              <a:t>pessoas beneficiadas</a:t>
+            </a:r>
+          </a:p>
+        </p:txBody>
+      </p:sp>
+      <p:sp>
+        <p:nvSpPr>
+          <p:cNvPr id="8" name="TextBox 7"/>
+          <p:cNvSpPr txBox="1"/>
+          <p:nvPr/>
+        </p:nvSpPr>
+        <p:spPr>
+          <a:xfrm>
+            <a:off x="8414891" y="2933700"/>
+            <a:ext cx="2410717" cy="958850"/>
+          </a:xfrm>
+          <a:prstGeom prst="rect">
+            <a:avLst/>
+          </a:prstGeom>
+          <a:noFill/>
+        </p:spPr>
+        <p:txBody>
+          <a:bodyPr wrap="none" lIns="0" rIns="0" tIns="0" bIns="0" anchor="t">
+            <a:spAutoFit/>
+          </a:bodyPr>
+          <a:lstStyle/>
+          <a:p>
+            <a:r>
+              <a:rPr sz="7500">
+                <a:solidFill>
+                  <a:srgbClr val="FF6F68"/>
+                </a:solidFill>
+                <a:latin typeface="Intro Bold"/>
+              </a:rPr>
+              <a:t>+200</a:t>
+            </a:r>
+          </a:p>
+        </p:txBody>
+      </p:sp>
+      <p:sp>
+        <p:nvSpPr>
+          <p:cNvPr id="9" name="TextBox 8"/>
+          <p:cNvSpPr txBox="1"/>
+          <p:nvPr/>
+        </p:nvSpPr>
+        <p:spPr>
+          <a:xfrm>
+            <a:off x="8206730" y="4133850"/>
+            <a:ext cx="2827039" cy="247650"/>
+          </a:xfrm>
+          <a:prstGeom prst="rect">
+            <a:avLst/>
+          </a:prstGeom>
+          <a:noFill/>
+        </p:spPr>
+        <p:txBody>
+          <a:bodyPr wrap="none" lIns="0" rIns="0" tIns="0" bIns="0" anchor="t">
+            <a:spAutoFit/>
+          </a:bodyPr>
+          <a:lstStyle/>
+          <a:p>
+            <a:r>
+              <a:rPr sz="1900">
                 <a:solidFill>
                   <a:srgbClr val="4B0F2F"/>
                 </a:solidFill>
                 <a:latin typeface="Intro Bold"/>
               </a:rPr>
-              <a:t>Mais de 12 especialidades</a:t>
-            </a:r>
-          </a:p>
-        </p:txBody>
-      </p:sp>
-      <p:sp>
-        <p:nvSpPr>
-          <p:cNvPr id="8" name="TextBox 7"/>
-          <p:cNvSpPr txBox="1"/>
-          <p:nvPr/>
-        </p:nvSpPr>
-        <p:spPr>
-          <a:xfrm>
-            <a:off x="1244600" y="4596257"/>
-            <a:ext cx="2163365" cy="203200"/>
-          </a:xfrm>
-          <a:prstGeom prst="rect">
-            <a:avLst/>
-          </a:prstGeom>
-          <a:noFill/>
-        </p:spPr>
-        <p:txBody>
-          <a:bodyPr wrap="none" lIns="0" rIns="0" tIns="0" bIns="0" anchor="t">
-            <a:spAutoFit/>
-          </a:bodyPr>
-          <a:lstStyle/>
-          <a:p>
-            <a:r>
-              <a:rPr sz="1550">
-                <a:solidFill>
-                  <a:srgbClr val="4B0F2F"/>
-                </a:solidFill>
-                <a:latin typeface="Intro Bold"/>
-              </a:rPr>
-              <a:t>Psicologia e nutrição</a:t>
-            </a:r>
-          </a:p>
-        </p:txBody>
-      </p:sp>
-      <p:sp>
-        <p:nvSpPr>
-          <p:cNvPr id="9" name="TextBox 8"/>
-          <p:cNvSpPr txBox="1"/>
-          <p:nvPr/>
-        </p:nvSpPr>
-        <p:spPr>
-          <a:xfrm>
-            <a:off x="1244600" y="5253482"/>
-            <a:ext cx="3952875" cy="203200"/>
-          </a:xfrm>
-          <a:prstGeom prst="rect">
-            <a:avLst/>
-          </a:prstGeom>
-          <a:noFill/>
-        </p:spPr>
-        <p:txBody>
-          <a:bodyPr wrap="none" lIns="0" rIns="0" tIns="0" bIns="0" anchor="t">
-            <a:spAutoFit/>
-          </a:bodyPr>
-          <a:lstStyle/>
-          <a:p>
-            <a:r>
-              <a:rPr sz="1550">
-                <a:solidFill>
-                  <a:srgbClr val="4B0F2F"/>
-                </a:solidFill>
-                <a:latin typeface="Intro Bold"/>
-              </a:rPr>
-              <a:t>Clubes de benefícios nacional e regional</a:t>
+              <a:t>profissionais parceiros</a:t>
+            </a:r>
+          </a:p>
+        </p:txBody>
+      </p:sp>
+      <p:sp>
+        <p:nvSpPr>
+          <p:cNvPr id="10" name="TextBox 9"/>
+          <p:cNvSpPr txBox="1"/>
+          <p:nvPr/>
+        </p:nvSpPr>
+        <p:spPr>
+          <a:xfrm>
+            <a:off x="4134445" y="5137150"/>
+            <a:ext cx="4113609" cy="196850"/>
+          </a:xfrm>
+          <a:prstGeom prst="rect">
+            <a:avLst/>
+          </a:prstGeom>
+          <a:noFill/>
+        </p:spPr>
+        <p:txBody>
+          <a:bodyPr wrap="none" lIns="0" rIns="0" tIns="0" bIns="0" anchor="t">
+            <a:spAutoFit/>
+          </a:bodyPr>
+          <a:lstStyle/>
+          <a:p>
+            <a:r>
+              <a:rPr sz="1500">
+                <a:solidFill>
+                  <a:srgbClr val="8C6E7D"/>
+                </a:solidFill>
+                <a:latin typeface="Intro Book"/>
+              </a:rPr>
+              <a:t>No Ceará, Rio Grande do Norte e Maranhão.</a:t>
             </a:r>
           </a:p>
         </p:txBody>
@@ -4596,28 +4663,28 @@
         </p:nvSpPr>
         <p:spPr>
           <a:xfrm>
-            <a:off x="1687859" y="1543050"/>
-            <a:ext cx="9006780" cy="533400"/>
-          </a:xfrm>
-          <a:prstGeom prst="rect">
-            <a:avLst/>
-          </a:prstGeom>
-          <a:noFill/>
-        </p:spPr>
-        <p:txBody>
-          <a:bodyPr wrap="none" lIns="0" rIns="0" tIns="0" bIns="0" anchor="t">
-            <a:spAutoFit/>
-          </a:bodyPr>
-          <a:lstStyle/>
-          <a:p>
-            <a:r>
-              <a:rPr sz="4200">
+            <a:off x="698500" y="2556891"/>
+            <a:ext cx="4717057" cy="527050"/>
+          </a:xfrm>
+          <a:prstGeom prst="rect">
+            <a:avLst/>
+          </a:prstGeom>
+          <a:noFill/>
+        </p:spPr>
+        <p:txBody>
+          <a:bodyPr wrap="none" lIns="0" rIns="0" tIns="0" bIns="0" anchor="t">
+            <a:spAutoFit/>
+          </a:bodyPr>
+          <a:lstStyle/>
+          <a:p>
+            <a:r>
+              <a:rPr sz="4100">
                 <a:solidFill>
                   <a:srgbClr val="4B0F2F"/>
                 </a:solidFill>
                 <a:latin typeface="Intro Bold"/>
               </a:rPr>
-              <a:t>Quem já escolheu cuidar da equipe</a:t>
+              <a:t>Cuidar de pessoas</a:t>
             </a:r>
           </a:p>
         </p:txBody>
@@ -4630,232 +4697,96 @@
         </p:nvSpPr>
         <p:spPr>
           <a:xfrm>
-            <a:off x="1849288" y="2933700"/>
-            <a:ext cx="1825922" cy="958850"/>
-          </a:xfrm>
-          <a:prstGeom prst="rect">
-            <a:avLst/>
-          </a:prstGeom>
-          <a:noFill/>
-        </p:spPr>
-        <p:txBody>
-          <a:bodyPr wrap="none" lIns="0" rIns="0" tIns="0" bIns="0" anchor="t">
-            <a:spAutoFit/>
-          </a:bodyPr>
-          <a:lstStyle/>
-          <a:p>
-            <a:r>
-              <a:rPr sz="7500">
+            <a:off x="698500" y="3140075"/>
+            <a:ext cx="4202211" cy="527050"/>
+          </a:xfrm>
+          <a:prstGeom prst="rect">
+            <a:avLst/>
+          </a:prstGeom>
+          <a:noFill/>
+        </p:spPr>
+        <p:txBody>
+          <a:bodyPr wrap="none" lIns="0" rIns="0" tIns="0" bIns="0" anchor="t">
+            <a:spAutoFit/>
+          </a:bodyPr>
+          <a:lstStyle/>
+          <a:p>
+            <a:r>
+              <a:rPr sz="4100">
+                <a:solidFill>
+                  <a:srgbClr val="4B0F2F"/>
+                </a:solidFill>
+                <a:latin typeface="Intro Bold"/>
+              </a:rPr>
+              <a:t>é fazer negócios</a:t>
+            </a:r>
+          </a:p>
+        </p:txBody>
+      </p:sp>
+      <p:sp>
+        <p:nvSpPr>
+          <p:cNvPr id="5" name="TextBox 4"/>
+          <p:cNvSpPr txBox="1"/>
+          <p:nvPr/>
+        </p:nvSpPr>
+        <p:spPr>
+          <a:xfrm>
+            <a:off x="698500" y="3723258"/>
+            <a:ext cx="687288" cy="527050"/>
+          </a:xfrm>
+          <a:prstGeom prst="rect">
+            <a:avLst/>
+          </a:prstGeom>
+          <a:noFill/>
+        </p:spPr>
+        <p:txBody>
+          <a:bodyPr wrap="none" lIns="0" rIns="0" tIns="0" bIns="0" anchor="t">
+            <a:spAutoFit/>
+          </a:bodyPr>
+          <a:lstStyle/>
+          <a:p>
+            <a:r>
+              <a:rPr sz="4100">
+                <a:solidFill>
+                  <a:srgbClr val="4B0F2F"/>
+                </a:solidFill>
+                <a:latin typeface="Intro Bold"/>
+              </a:rPr>
+              <a:t>ir </a:t>
+            </a:r>
+          </a:p>
+        </p:txBody>
+      </p:sp>
+      <p:sp>
+        <p:nvSpPr>
+          <p:cNvPr id="6" name="TextBox 5"/>
+          <p:cNvSpPr txBox="1"/>
+          <p:nvPr/>
+        </p:nvSpPr>
+        <p:spPr>
+          <a:xfrm>
+            <a:off x="1195288" y="3723258"/>
+            <a:ext cx="3002260" cy="527050"/>
+          </a:xfrm>
+          <a:prstGeom prst="rect">
+            <a:avLst/>
+          </a:prstGeom>
+          <a:noFill/>
+        </p:spPr>
+        <p:txBody>
+          <a:bodyPr wrap="none" lIns="0" rIns="0" tIns="0" bIns="0" anchor="t">
+            <a:spAutoFit/>
+          </a:bodyPr>
+          <a:lstStyle/>
+          <a:p>
+            <a:r>
+              <a:rPr sz="4100">
                 <a:solidFill>
                   <a:srgbClr val="FF6F68"/>
                 </a:solidFill>
                 <a:latin typeface="Intro Bold"/>
               </a:rPr>
-              <a:t>+50</a:t>
-            </a:r>
-          </a:p>
-        </p:txBody>
-      </p:sp>
-      <p:sp>
-        <p:nvSpPr>
-          <p:cNvPr id="5" name="TextBox 4"/>
-          <p:cNvSpPr txBox="1"/>
-          <p:nvPr/>
-        </p:nvSpPr>
-        <p:spPr>
-          <a:xfrm>
-            <a:off x="1617960" y="4133850"/>
-            <a:ext cx="2288579" cy="247650"/>
-          </a:xfrm>
-          <a:prstGeom prst="rect">
-            <a:avLst/>
-          </a:prstGeom>
-          <a:noFill/>
-        </p:spPr>
-        <p:txBody>
-          <a:bodyPr wrap="none" lIns="0" rIns="0" tIns="0" bIns="0" anchor="t">
-            <a:spAutoFit/>
-          </a:bodyPr>
-          <a:lstStyle/>
-          <a:p>
-            <a:r>
-              <a:rPr sz="1900">
-                <a:solidFill>
-                  <a:srgbClr val="4B0F2F"/>
-                </a:solidFill>
-                <a:latin typeface="Intro Bold"/>
-              </a:rPr>
-              <a:t>empresas clientes</a:t>
-            </a:r>
-          </a:p>
-        </p:txBody>
-      </p:sp>
-      <p:sp>
-        <p:nvSpPr>
-          <p:cNvPr id="6" name="TextBox 5"/>
-          <p:cNvSpPr txBox="1"/>
-          <p:nvPr/>
-        </p:nvSpPr>
-        <p:spPr>
-          <a:xfrm>
-            <a:off x="4832796" y="3067050"/>
-            <a:ext cx="2716907" cy="781050"/>
-          </a:xfrm>
-          <a:prstGeom prst="rect">
-            <a:avLst/>
-          </a:prstGeom>
-          <a:noFill/>
-        </p:spPr>
-        <p:txBody>
-          <a:bodyPr wrap="none" lIns="0" rIns="0" tIns="0" bIns="0" anchor="t">
-            <a:spAutoFit/>
-          </a:bodyPr>
-          <a:lstStyle/>
-          <a:p>
-            <a:r>
-              <a:rPr sz="6100">
-                <a:solidFill>
-                  <a:srgbClr val="FF6F68"/>
-                </a:solidFill>
-                <a:latin typeface="Intro Bold"/>
-              </a:rPr>
-              <a:t>+2.000</a:t>
-            </a:r>
-          </a:p>
-        </p:txBody>
-      </p:sp>
-      <p:sp>
-        <p:nvSpPr>
-          <p:cNvPr id="7" name="TextBox 6"/>
-          <p:cNvSpPr txBox="1"/>
-          <p:nvPr/>
-        </p:nvSpPr>
-        <p:spPr>
-          <a:xfrm>
-            <a:off x="4876651" y="4133850"/>
-            <a:ext cx="2629197" cy="247650"/>
-          </a:xfrm>
-          <a:prstGeom prst="rect">
-            <a:avLst/>
-          </a:prstGeom>
-          <a:noFill/>
-        </p:spPr>
-        <p:txBody>
-          <a:bodyPr wrap="none" lIns="0" rIns="0" tIns="0" bIns="0" anchor="t">
-            <a:spAutoFit/>
-          </a:bodyPr>
-          <a:lstStyle/>
-          <a:p>
-            <a:r>
-              <a:rPr sz="1900">
-                <a:solidFill>
-                  <a:srgbClr val="4B0F2F"/>
-                </a:solidFill>
-                <a:latin typeface="Intro Bold"/>
-              </a:rPr>
-              <a:t>pessoas beneficiadas</a:t>
-            </a:r>
-          </a:p>
-        </p:txBody>
-      </p:sp>
-      <p:sp>
-        <p:nvSpPr>
-          <p:cNvPr id="8" name="TextBox 7"/>
-          <p:cNvSpPr txBox="1"/>
-          <p:nvPr/>
-        </p:nvSpPr>
-        <p:spPr>
-          <a:xfrm>
-            <a:off x="8414891" y="2933700"/>
-            <a:ext cx="2410717" cy="958850"/>
-          </a:xfrm>
-          <a:prstGeom prst="rect">
-            <a:avLst/>
-          </a:prstGeom>
-          <a:noFill/>
-        </p:spPr>
-        <p:txBody>
-          <a:bodyPr wrap="none" lIns="0" rIns="0" tIns="0" bIns="0" anchor="t">
-            <a:spAutoFit/>
-          </a:bodyPr>
-          <a:lstStyle/>
-          <a:p>
-            <a:r>
-              <a:rPr sz="7500">
-                <a:solidFill>
-                  <a:srgbClr val="FF6F68"/>
-                </a:solidFill>
-                <a:latin typeface="Intro Bold"/>
-              </a:rPr>
-              <a:t>+200</a:t>
-            </a:r>
-          </a:p>
-        </p:txBody>
-      </p:sp>
-      <p:sp>
-        <p:nvSpPr>
-          <p:cNvPr id="9" name="TextBox 8"/>
-          <p:cNvSpPr txBox="1"/>
-          <p:nvPr/>
-        </p:nvSpPr>
-        <p:spPr>
-          <a:xfrm>
-            <a:off x="8206730" y="4133850"/>
-            <a:ext cx="2827039" cy="247650"/>
-          </a:xfrm>
-          <a:prstGeom prst="rect">
-            <a:avLst/>
-          </a:prstGeom>
-          <a:noFill/>
-        </p:spPr>
-        <p:txBody>
-          <a:bodyPr wrap="none" lIns="0" rIns="0" tIns="0" bIns="0" anchor="t">
-            <a:spAutoFit/>
-          </a:bodyPr>
-          <a:lstStyle/>
-          <a:p>
-            <a:r>
-              <a:rPr sz="1900">
-                <a:solidFill>
-                  <a:srgbClr val="4B0F2F"/>
-                </a:solidFill>
-                <a:latin typeface="Intro Bold"/>
-              </a:rPr>
-              <a:t>profissionais parceiros</a:t>
-            </a:r>
-          </a:p>
-        </p:txBody>
-      </p:sp>
-      <p:sp>
-        <p:nvSpPr>
-          <p:cNvPr id="10" name="TextBox 9"/>
-          <p:cNvSpPr txBox="1"/>
-          <p:nvPr/>
-        </p:nvSpPr>
-        <p:spPr>
-          <a:xfrm>
-            <a:off x="4134445" y="5137150"/>
-            <a:ext cx="4113609" cy="196850"/>
-          </a:xfrm>
-          <a:prstGeom prst="rect">
-            <a:avLst/>
-          </a:prstGeom>
-          <a:noFill/>
-        </p:spPr>
-        <p:txBody>
-          <a:bodyPr wrap="none" lIns="0" rIns="0" tIns="0" bIns="0" anchor="t">
-            <a:spAutoFit/>
-          </a:bodyPr>
-          <a:lstStyle/>
-          <a:p>
-            <a:r>
-              <a:rPr sz="1500">
-                <a:solidFill>
-                  <a:srgbClr val="8C6E7D"/>
-                </a:solidFill>
-                <a:latin typeface="Intro Book"/>
-              </a:rPr>
-              <a:t>No Ceará, Rio Grande do Norte e Maranhão.</a:t>
+              <a:t>mais longe.</a:t>
             </a:r>
           </a:p>
         </p:txBody>
@@ -4884,187 +4815,6 @@
       <p:pic>
         <p:nvPicPr>
           <p:cNvPr id="2" name="Picture 1" descr="tela_16.png"/>
-          <p:cNvPicPr>
-            <a:picLocks noChangeAspect="1"/>
-          </p:cNvPicPr>
-          <p:nvPr/>
-        </p:nvPicPr>
-        <p:blipFill>
-          <a:blip r:embed="rId2"/>
-          <a:stretch>
-            <a:fillRect/>
-          </a:stretch>
-        </p:blipFill>
-        <p:spPr>
-          <a:xfrm>
-            <a:off x="0" y="0"/>
-            <a:ext cx="12192000" cy="6858000"/>
-          </a:xfrm>
-          <a:prstGeom prst="rect">
-            <a:avLst/>
-          </a:prstGeom>
-        </p:spPr>
-      </p:pic>
-      <p:sp>
-        <p:nvSpPr>
-          <p:cNvPr id="3" name="TextBox 2"/>
-          <p:cNvSpPr txBox="1"/>
-          <p:nvPr/>
-        </p:nvSpPr>
-        <p:spPr>
-          <a:xfrm>
-            <a:off x="698500" y="2556891"/>
-            <a:ext cx="4717057" cy="527050"/>
-          </a:xfrm>
-          <a:prstGeom prst="rect">
-            <a:avLst/>
-          </a:prstGeom>
-          <a:noFill/>
-        </p:spPr>
-        <p:txBody>
-          <a:bodyPr wrap="none" lIns="0" rIns="0" tIns="0" bIns="0" anchor="t">
-            <a:spAutoFit/>
-          </a:bodyPr>
-          <a:lstStyle/>
-          <a:p>
-            <a:r>
-              <a:rPr sz="4100">
-                <a:solidFill>
-                  <a:srgbClr val="4B0F2F"/>
-                </a:solidFill>
-                <a:latin typeface="Intro Bold"/>
-              </a:rPr>
-              <a:t>Cuidar de pessoas</a:t>
-            </a:r>
-          </a:p>
-        </p:txBody>
-      </p:sp>
-      <p:sp>
-        <p:nvSpPr>
-          <p:cNvPr id="4" name="TextBox 3"/>
-          <p:cNvSpPr txBox="1"/>
-          <p:nvPr/>
-        </p:nvSpPr>
-        <p:spPr>
-          <a:xfrm>
-            <a:off x="698500" y="3140075"/>
-            <a:ext cx="4202211" cy="527050"/>
-          </a:xfrm>
-          <a:prstGeom prst="rect">
-            <a:avLst/>
-          </a:prstGeom>
-          <a:noFill/>
-        </p:spPr>
-        <p:txBody>
-          <a:bodyPr wrap="none" lIns="0" rIns="0" tIns="0" bIns="0" anchor="t">
-            <a:spAutoFit/>
-          </a:bodyPr>
-          <a:lstStyle/>
-          <a:p>
-            <a:r>
-              <a:rPr sz="4100">
-                <a:solidFill>
-                  <a:srgbClr val="4B0F2F"/>
-                </a:solidFill>
-                <a:latin typeface="Intro Bold"/>
-              </a:rPr>
-              <a:t>é fazer negócios</a:t>
-            </a:r>
-          </a:p>
-        </p:txBody>
-      </p:sp>
-      <p:sp>
-        <p:nvSpPr>
-          <p:cNvPr id="5" name="TextBox 4"/>
-          <p:cNvSpPr txBox="1"/>
-          <p:nvPr/>
-        </p:nvSpPr>
-        <p:spPr>
-          <a:xfrm>
-            <a:off x="698500" y="3723258"/>
-            <a:ext cx="687288" cy="527050"/>
-          </a:xfrm>
-          <a:prstGeom prst="rect">
-            <a:avLst/>
-          </a:prstGeom>
-          <a:noFill/>
-        </p:spPr>
-        <p:txBody>
-          <a:bodyPr wrap="none" lIns="0" rIns="0" tIns="0" bIns="0" anchor="t">
-            <a:spAutoFit/>
-          </a:bodyPr>
-          <a:lstStyle/>
-          <a:p>
-            <a:r>
-              <a:rPr sz="4100">
-                <a:solidFill>
-                  <a:srgbClr val="4B0F2F"/>
-                </a:solidFill>
-                <a:latin typeface="Intro Bold"/>
-              </a:rPr>
-              <a:t>ir </a:t>
-            </a:r>
-          </a:p>
-        </p:txBody>
-      </p:sp>
-      <p:sp>
-        <p:nvSpPr>
-          <p:cNvPr id="6" name="TextBox 5"/>
-          <p:cNvSpPr txBox="1"/>
-          <p:nvPr/>
-        </p:nvSpPr>
-        <p:spPr>
-          <a:xfrm>
-            <a:off x="1195288" y="3723258"/>
-            <a:ext cx="3002260" cy="527050"/>
-          </a:xfrm>
-          <a:prstGeom prst="rect">
-            <a:avLst/>
-          </a:prstGeom>
-          <a:noFill/>
-        </p:spPr>
-        <p:txBody>
-          <a:bodyPr wrap="none" lIns="0" rIns="0" tIns="0" bIns="0" anchor="t">
-            <a:spAutoFit/>
-          </a:bodyPr>
-          <a:lstStyle/>
-          <a:p>
-            <a:r>
-              <a:rPr sz="4100">
-                <a:solidFill>
-                  <a:srgbClr val="FF6F68"/>
-                </a:solidFill>
-                <a:latin typeface="Intro Bold"/>
-              </a:rPr>
-              <a:t>mais longe.</a:t>
-            </a:r>
-          </a:p>
-        </p:txBody>
-      </p:sp>
-    </p:spTree>
-  </p:cSld>
-  <p:clrMapOvr>
-    <a:masterClrMapping/>
-  </p:clrMapOvr>
-  <p:transition spd="med" advTm="9000">
-    <p:fade/>
-  </p:transition>
-</p:sld>
-</file>
-
-<file path=ppt/slides/slide17.xml><?xml version="1.0" encoding="utf-8"?>
-<p:sld xmlns:a="http://schemas.openxmlformats.org/drawingml/2006/main" xmlns:p="http://schemas.openxmlformats.org/presentationml/2006/main" xmlns:r="http://schemas.openxmlformats.org/officeDocument/2006/relationships">
-  <p:cSld>
-    <p:spTree>
-      <p:nvGrpSpPr>
-        <p:cNvPr id="1" name=""/>
-        <p:cNvGrpSpPr/>
-        <p:nvPr/>
-      </p:nvGrpSpPr>
-      <p:grpSpPr/>
-      <p:pic>
-        <p:nvPicPr>
-          <p:cNvPr id="2" name="Picture 1" descr="tela_17.png"/>
           <p:cNvPicPr>
             <a:picLocks noChangeAspect="1"/>
           </p:cNvPicPr>

</xml_diff>